<commit_message>
Rebuild F4 and F2T in the v3 format; fix cover title on all decks
F4 (46) and F2T (24) decks now follow the teacher's model: board summary
points following the syllabus with announcing sentences and one sentence
per point, MINESEC sheet, slide master with DGCAST-GAROUA footer, speaker
notes, homework correction, lesson plan, action to take and next lesson.
The cover no longer repeats the lesson title; LSA and USA decks rebuilt.
Files lose the old _v2 suffix.

Co-Authored-By: Claude Opus 5.5 <noreply@anthropic.com>
Claude-Session: https://claude.ai/code/session_0115LFSb2ktGLWPeVksFkSer
</commit_message>
<xml_diff>
--- a/lecons/LSA/Climatology/LSA_CLIM_FS01_Tropical_Weather_Disturbances.pptx
+++ b/lecons/LSA/Climatology/LSA_CLIM_FS01_Tropical_Weather_Disturbances.pptx
@@ -3023,7 +3023,7 @@
           <a:p>
             <a:r>
               <a:rPr lang="en-US" dirty="0"/>
-              <a:t>Let us copy DEFINITIONS. The key terms of this lesson are defined as follows. Write each point on a new line, with the key term first. When you finish, we go to the next slide.</a:t>
+              <a:t>Let us copy the definitions. The key terms of this lesson are defined as follows. On this slide we have Thunderstorm. Write each point on a new line, with the key term first, and explain it in your own words when we revise. When you finish, we go to the next slide.</a:t>
             </a:r>
             <a:endParaRPr lang="en-US" dirty="0"/>
           </a:p>
@@ -3111,7 +3111,7 @@
           <a:p>
             <a:r>
               <a:rPr lang="en-US" dirty="0"/>
-              <a:t>We continue with the same part. Write each point on a new line, with the key term first.</a:t>
+              <a:t>We continue with the definitions. On this slide we have Tropical cyclone. Write each point on a new line, with the key term first, and explain it in your own words when we revise.</a:t>
             </a:r>
             <a:endParaRPr lang="en-US" dirty="0"/>
           </a:p>
@@ -3199,7 +3199,7 @@
           <a:p>
             <a:r>
               <a:rPr lang="en-US" dirty="0"/>
-              <a:t>Let us copy Thunderstorms. Thunderstorms can be studied under the following points. Write each point on a new line, with the key term first. When you finish, we go to the next slide.</a:t>
+              <a:t>Let us copy Thunderstorms. Thunderstorms can be studied under the following points. On this slide we have Formation. Write each point on a new line, with the key term first, and explain it in your own words when we revise. When you finish, we go to the next slide.</a:t>
             </a:r>
             <a:endParaRPr lang="en-US" dirty="0"/>
           </a:p>
@@ -3287,7 +3287,7 @@
           <a:p>
             <a:r>
               <a:rPr lang="en-US" dirty="0"/>
-              <a:t>We continue with the same part. Write each point on a new line, with the key term first. When you finish, we go to the next slide.</a:t>
+              <a:t>We continue with Thunderstorms. On this slide we have Stages. Write each point on a new line, with the key term first, and explain it in your own words when we revise. When you finish, we go to the next slide.</a:t>
             </a:r>
             <a:endParaRPr lang="en-US" dirty="0"/>
           </a:p>
@@ -3375,7 +3375,7 @@
           <a:p>
             <a:r>
               <a:rPr lang="en-US" dirty="0"/>
-              <a:t>We continue with the same part. Write each point on a new line, with the key term first.</a:t>
+              <a:t>We continue with Thunderstorms. On this slide we have Effects. Write each point on a new line, with the key term first, and explain it in your own words when we revise.</a:t>
             </a:r>
             <a:endParaRPr lang="en-US" dirty="0"/>
           </a:p>
@@ -3639,7 +3639,7 @@
           <a:p>
             <a:r>
               <a:rPr lang="en-US" dirty="0"/>
-              <a:t>Let us copy Tropical Cyclones. Tropical cyclones can be studied as follows. Write each point on a new line, with the key term first. When you finish, we go to the next slide.</a:t>
+              <a:t>Let us copy Tropical Cyclones. Tropical cyclones can be studied as follows. On this slide we have Conditions of formation. Write each point on a new line, with the key term first, and explain it in your own words when we revise. When you finish, we go to the next slide.</a:t>
             </a:r>
             <a:endParaRPr lang="en-US" dirty="0"/>
           </a:p>
@@ -3727,7 +3727,7 @@
           <a:p>
             <a:r>
               <a:rPr lang="en-US" dirty="0"/>
-              <a:t>We continue with the same part. Write each point on a new line, with the key term first. When you finish, we go to the next slide.</a:t>
+              <a:t>We continue with Tropical Cyclones. On this slide we have Structure. Write each point on a new line, with the key term first, and explain it in your own words when we revise. When you finish, we go to the next slide.</a:t>
             </a:r>
             <a:endParaRPr lang="en-US" dirty="0"/>
           </a:p>
@@ -3815,7 +3815,7 @@
           <a:p>
             <a:r>
               <a:rPr lang="en-US" dirty="0"/>
-              <a:t>We continue with the same part. Write each point on a new line, with the key term first.</a:t>
+              <a:t>We continue with Tropical Cyclones. On this slide we have Names and areas. Write each point on a new line, with the key term first, and explain it in your own words when we revise.</a:t>
             </a:r>
             <a:endParaRPr lang="en-US" dirty="0"/>
           </a:p>
@@ -3991,7 +3991,7 @@
           <a:p>
             <a:r>
               <a:rPr lang="en-US" dirty="0"/>
-              <a:t>Let us copy Effects and Control. The effects and control of tropical disturbances are. Write each point on a new line, with the key term first. When you finish, we go to the next slide.</a:t>
+              <a:t>Let us copy Effects and Control. The effects and control of tropical disturbances are. On this slide we have Effects. Write each point on a new line, with the key term first, and explain it in your own words when we revise. When you finish, we go to the next slide.</a:t>
             </a:r>
             <a:endParaRPr lang="en-US" dirty="0"/>
           </a:p>
@@ -4079,7 +4079,7 @@
           <a:p>
             <a:r>
               <a:rPr lang="en-US" dirty="0"/>
-              <a:t>We continue with the same part. Write each point on a new line, with the key term first.</a:t>
+              <a:t>We continue with Effects and Control. On this slide we have Control and prevention. Write each point on a new line, with the key term first, and explain it in your own words when we revise.</a:t>
             </a:r>
             <a:endParaRPr lang="en-US" dirty="0"/>
           </a:p>
@@ -5311,7 +5311,7 @@
           <a:p>
             <a:r>
               <a:rPr lang="en-US" dirty="0"/>
-              <a:t>Here is the plan of our lesson today. We shall correction of the homework; then objectives and recall; then real-life situation and action to take; then learning activities; then board summary; then evaluation, remediation and homework.</a:t>
+              <a:t>Here is the plan of our lesson today. First, we shall correct the homework. Then we shall look at the objectives and recall what you already know. After that, we shall study a situation from real life and the action to take, and do the learning activities. Finally, we shall copy the board summary, do the evaluation and the remediation, and I will give you the homework.</a:t>
             </a:r>
             <a:endParaRPr lang="en-US" dirty="0"/>
           </a:p>
@@ -6851,7 +6851,7 @@
                 <a:ea typeface="Times New Roman" pitchFamily="34" charset="-122"/>
                 <a:cs typeface="Times New Roman" pitchFamily="34" charset="-120"/>
               </a:rPr>
-              <a:t>Further Study 1: Tropical Weather Disturbances</a:t>
+              <a:t>Further Study 1</a:t>
             </a:r>
             <a:endParaRPr lang="en-US" sz="2600" dirty="0"/>
           </a:p>

</xml_diff>